<commit_message>
Update 3Q2026 Contest PowerPoint presentation
</commit_message>
<xml_diff>
--- a/3Q2026 Contest.pptx
+++ b/3Q2026 Contest.pptx
@@ -1902,7 +1902,7 @@
                 <a:ea typeface="Segoe UI" pitchFamily="34" charset="-122"/>
                 <a:cs typeface="Segoe UI" pitchFamily="34" charset="-120"/>
               </a:rPr>
-              <a:t>A two-month enrollment contest for CTAMs and RADs</a:t>
+              <a:t>A two-month enrollment contest for CTAM territories and RADs</a:t>
             </a:r>
             <a:endParaRPr lang="en-US" sz="1400" dirty="0"/>
           </a:p>
@@ -1941,7 +1941,7 @@
                 <a:ea typeface="Segoe UI" pitchFamily="34" charset="-122"/>
                 <a:cs typeface="Segoe UI" pitchFamily="34" charset="-120"/>
               </a:rPr>
-              <a:t>Runs August 15 to October 15, 2026.  Prepared August 2026.</a:t>
+              <a:t>Contest window August 15 to October 15, 2026.  Prepared August 2026.</a:t>
             </a:r>
             <a:endParaRPr lang="en-US" sz="1200" dirty="0"/>
           </a:p>
@@ -2655,7 +2655,7 @@
                 <a:ea typeface="Segoe UI" pitchFamily="34" charset="-122"/>
                 <a:cs typeface="Segoe UI" pitchFamily="34" charset="-120"/>
               </a:rPr>
-              <a:t>Up from 50-70</a:t>
+              <a:t>Up from 50 to 70</a:t>
             </a:r>
             <a:endParaRPr lang="en-US" sz="1200" dirty="0"/>
           </a:p>
@@ -2812,7 +2812,7 @@
                 <a:ea typeface="Segoe UI" pitchFamily="34" charset="-122"/>
                 <a:cs typeface="Segoe UI" pitchFamily="34" charset="-120"/>
               </a:rPr>
-              <a:t>Down from about 27, and the goal is 25 or more</a:t>
+              <a:t>Against a target of 25, down from roughly 27</a:t>
             </a:r>
             <a:endParaRPr lang="en-US" sz="1200" dirty="0"/>
           </a:p>
@@ -3223,7 +3223,7 @@
                 <a:ea typeface="Segoe UI" pitchFamily="34" charset="-122"/>
                 <a:cs typeface="Segoe UI" pitchFamily="34" charset="-120"/>
               </a:rPr>
-              <a:t>pushes here</a:t>
+              <a:t>targets this step</a:t>
             </a:r>
             <a:endParaRPr lang="en-US" sz="1100" dirty="0"/>
           </a:p>
@@ -3262,7 +3262,7 @@
                 <a:ea typeface="Segoe UI" pitchFamily="34" charset="-122"/>
                 <a:cs typeface="Segoe UI" pitchFamily="34" charset="-120"/>
               </a:rPr>
-              <a:t>Revenue lands here. The IC plan already rewards this step.</a:t>
+              <a:t>Revenue lands at this step, which the IC plan already compensates.</a:t>
             </a:r>
             <a:endParaRPr lang="en-US" sz="1050" dirty="0"/>
           </a:p>
@@ -3301,7 +3301,7 @@
                 <a:ea typeface="Segoe UI" pitchFamily="34" charset="-122"/>
                 <a:cs typeface="Segoe UI" pitchFamily="34" charset="-120"/>
               </a:rPr>
-              <a:t>Capacity, enrollment, and funnel figures are the team's current numbers for 2H 2026.</a:t>
+              <a:t>Capacity, enrollment and funnel figures are the current 2H 2026 planning numbers.</a:t>
             </a:r>
             <a:endParaRPr lang="en-US" sz="850" dirty="0"/>
           </a:p>
@@ -3852,7 +3852,7 @@
                 </a:solidFill>
                 <a:latin typeface="Segoe UI"/>
               </a:rPr>
-              <a:t>CTAM territories compete inside High, Medium and Low volume buckets.</a:t>
+              <a:t>CTAM territories compete within High, Medium and Low volume buckets.</a:t>
             </a:r>
           </a:p>
         </p:txBody>
@@ -4107,7 +4107,7 @@
                 </a:solidFill>
                 <a:latin typeface="Segoe UI"/>
               </a:rPr>
-              <a:t>For the conversion kicker the TTP has to occur by November 15, 2026.</a:t>
+              <a:t>For the conversion kicker, TTP must occur by November 15, 2026.</a:t>
             </a:r>
           </a:p>
         </p:txBody>
@@ -4320,7 +4320,7 @@
                 </a:solidFill>
                 <a:latin typeface="Segoe UI"/>
               </a:rPr>
-              <a:t>Ranking happens inside your own bucket, never against the whole country.</a:t>
+              <a:t>Ranking is within the bucket, never against the national field.</a:t>
             </a:r>
           </a:p>
         </p:txBody>
@@ -4491,7 +4491,7 @@
                 </a:solidFill>
                 <a:latin typeface="Segoe UI"/>
               </a:rPr>
-              <a:t>You have to finish above your baseline.</a:t>
+              <a:t>A territory must finish above its baseline.</a:t>
             </a:r>
           </a:p>
         </p:txBody>
@@ -4533,7 +4533,7 @@
                 </a:solidFill>
                 <a:latin typeface="Segoe UI"/>
               </a:rPr>
-              <a:t>The top three eligible territories in each volume bucket take a placement award.</a:t>
+              <a:t>The top three eligible territories in each bucket take a placement award.</a:t>
             </a:r>
           </a:p>
         </p:txBody>
@@ -4619,7 +4619,7 @@
                 </a:solidFill>
                 <a:latin typeface="Segoe UI"/>
               </a:rPr>
-              <a:t>This runs alongside your IC plan, not instead of it.</a:t>
+              <a:t>This runs alongside the IC plan, not in place of it.</a:t>
             </a:r>
             <a:r>
               <a:rPr sz="1200" b="0" i="0">
@@ -4628,7 +4628,7 @@
                 </a:solidFill>
                 <a:latin typeface="Segoe UI"/>
               </a:rPr>
-              <a:t>  The IC plan pays on infusions. This one pays on enrollments, the step before. Every award amount is on the payout slide.</a:t>
+              <a:t>  The IC plan compensates infusions. The contest rewards enrollments, the step before it. Award amounts are on the payout slide.</a:t>
             </a:r>
           </a:p>
         </p:txBody>
@@ -5096,7 +5096,7 @@
                 </a:solidFill>
                 <a:latin typeface="Segoe UI"/>
               </a:rPr>
-              <a:t>BEFORE: one national list</a:t>
+              <a:t>BEFORE: a single national ranking</a:t>
             </a:r>
           </a:p>
         </p:txBody>
@@ -5177,7 +5177,18 @@
                 <a:ea typeface="Segoe UI" pitchFamily="34" charset="-122"/>
                 <a:cs typeface="Segoe UI" pitchFamily="34" charset="-120"/>
               </a:rPr>
-              <a:t>So we bucket first.  If we simply counted enrollments, the highest volume territories would win every time and the rest could never catch up.</a:t>
+              <a:t>Bucketing comes first.</a:t>
+            </a:r>
+            <a:r>
+              <a:rPr lang="en-US" sz="1250" dirty="0">
+                <a:solidFill>
+                  <a:srgbClr val="17344F"/>
+                </a:solidFill>
+                <a:latin typeface="Segoe UI" pitchFamily="34" charset="0"/>
+                <a:ea typeface="Segoe UI" pitchFamily="34" charset="-122"/>
+                <a:cs typeface="Segoe UI" pitchFamily="34" charset="-120"/>
+              </a:rPr>
+              <a:t>  On a single enrollment count the highest volume territories win by default, and the rest have no realistic path to an award.</a:t>
             </a:r>
             <a:endParaRPr lang="en-US" sz="1250" dirty="0"/>
           </a:p>
@@ -5216,7 +5227,7 @@
                 <a:ea typeface="Segoe UI" pitchFamily="34" charset="-122"/>
                 <a:cs typeface="Segoe UI" pitchFamily="34" charset="-120"/>
               </a:rPr>
-              <a:t>Each bar is one territory, plotted on the baseline it has to beat. The three volume buckets are set and lock for the contest. Desert Plains is assigned to medium volume at leadership direction. The full roster of 28 territories and their baselines is in the appendix.</a:t>
+              <a:t>Each bar is one territory, plotted on its baseline. Bucket assignments are fixed for the duration of the contest. Desert Plains is assigned to medium volume at leadership direction. The full roster of 28 territories and their baselines is in the appendix.</a:t>
             </a:r>
             <a:endParaRPr lang="en-US" sz="850" dirty="0"/>
           </a:p>
@@ -5326,7 +5337,7 @@
                 </a:solidFill>
                 <a:latin typeface="Segoe UI"/>
               </a:rPr>
-              <a:t>High volume territories compete only against each other.</a:t>
+              <a:t>Ranked only against other high volume territories.</a:t>
             </a:r>
           </a:p>
         </p:txBody>
@@ -5435,7 +5446,7 @@
                 </a:solidFill>
                 <a:latin typeface="Segoe UI"/>
               </a:rPr>
-              <a:t>Medium volume territories are ranked only within their own bucket.</a:t>
+              <a:t>Ranked only against other medium volume territories.</a:t>
             </a:r>
           </a:p>
         </p:txBody>
@@ -5544,7 +5555,7 @@
                 </a:solidFill>
                 <a:latin typeface="Segoe UI"/>
               </a:rPr>
-              <a:t>Low volume territories get a fair shot at winning.</a:t>
+              <a:t>Ranked only against other low volume territories.</a:t>
             </a:r>
           </a:p>
         </p:txBody>
@@ -5638,7 +5649,7 @@
                 </a:solidFill>
                 <a:latin typeface="Segoe UI"/>
               </a:rPr>
-              <a:t>AFTER: grouped into volume buckets</a:t>
+              <a:t>AFTER: ranked within volume buckets</a:t>
             </a:r>
           </a:p>
         </p:txBody>
@@ -5670,7 +5681,7 @@
                 </a:solidFill>
                 <a:latin typeface="Segoe UI"/>
               </a:rPr>
-              <a:t>15 times the gap</a:t>
+              <a:t>A 15-fold spread</a:t>
             </a:r>
           </a:p>
           <a:p>
@@ -5681,7 +5692,7 @@
                 </a:solidFill>
                 <a:latin typeface="Segoe UI"/>
               </a:rPr>
-              <a:t>Baseline 15 at the top of the roster, 1 at the bottom</a:t>
+              <a:t>Baselines run from 15 at the top of the roster to 1 at the bottom</a:t>
             </a:r>
           </a:p>
         </p:txBody>
@@ -6366,7 +6377,7 @@
                 </a:solidFill>
                 <a:latin typeface="Segoe UI"/>
               </a:rPr>
-              <a:t> Everything enrolled between August 15 and October 15, 2026.</a:t>
+              <a:t> All enrollments between August 15 and October 15, 2026.</a:t>
             </a:r>
           </a:p>
         </p:txBody>
@@ -6761,7 +6772,7 @@
                 </a:solidFill>
                 <a:latin typeface="Segoe UI"/>
               </a:rPr>
-              <a:t> separately, against the other territories in your own volume bucket.</a:t>
+              <a:t> separately, against the other territories in the same volume bucket.</a:t>
             </a:r>
           </a:p>
         </p:txBody>
@@ -6865,7 +6876,7 @@
                 </a:solidFill>
                 <a:latin typeface="Segoe UI"/>
               </a:rPr>
-              <a:t> to get the final score. The lowest score is the best, so 1.0 means you ranked first on both.</a:t>
+              <a:t> to produce the final score. The lowest score wins, so 1.0 means first on both measures.</a:t>
             </a:r>
           </a:p>
         </p:txBody>
@@ -6969,7 +6980,7 @@
                 </a:solidFill>
                 <a:latin typeface="Segoe UI"/>
               </a:rPr>
-              <a:t> A territory at or below its baseline is out, whatever it scored.</a:t>
+              <a:t> A territory at or below its baseline is ineligible, whatever its score.</a:t>
             </a:r>
           </a:p>
         </p:txBody>
@@ -7073,7 +7084,7 @@
                 </a:solidFill>
                 <a:latin typeface="Segoe UI"/>
               </a:rPr>
-              <a:t> territories in each volume bucket. Ties go to the higher percent growth.</a:t>
+              <a:t> territories in each volume bucket. Ties are broken on the higher percent growth.</a:t>
             </a:r>
           </a:p>
         </p:txBody>
@@ -7159,7 +7170,7 @@
                 </a:solidFill>
                 <a:latin typeface="Segoe UI"/>
               </a:rPr>
-              <a:t>Step 7 is the one to remember.</a:t>
+              <a:t>Eligibility is the binding constraint.</a:t>
             </a:r>
             <a:r>
               <a:rPr sz="1200" b="0" i="0">
@@ -10873,7 +10884,7 @@
                 </a:solidFill>
                 <a:latin typeface="Segoe UI"/>
               </a:rPr>
-              <a:t>Read the tie:  </a:t>
+              <a:t>Tie-break:</a:t>
             </a:r>
             <a:r>
               <a:rPr sz="1100" b="0" i="0">
@@ -10882,7 +10893,7 @@
                 </a:solidFill>
                 <a:latin typeface="Segoe UI"/>
               </a:rPr>
-              <a:t>Territory B and Territory C both score 2.5. The higher percent growth wins, so Territory C takes second. Territory E ranked last on both measures and finished below its baseline, so it cannot place at all.</a:t>
+              <a:t>  Territory B and Territory C both score 2.5, and the higher percent growth takes precedence, so Territory C places second. Territory E finished below its baseline and is ineligible regardless of rank.</a:t>
             </a:r>
           </a:p>
         </p:txBody>
@@ -11106,7 +11117,7 @@
                 </a:solidFill>
                 <a:latin typeface="Segoe UI"/>
               </a:rPr>
-              <a:t>  It enrolled 10 and 8 of them reached TTP by November 15, an 80 percent pull-through and the best in the bucket. It wins the kicker even though it did not place, because the kicker is scored on pull-through and not on growth.</a:t>
+              <a:t>  It enrolled 10, of which 8 reached TTP by November 15, an 80 percent pull-through and the highest in the bucket. It takes the kicker without placing, because the kicker is scored on conversion rather than growth.</a:t>
             </a:r>
           </a:p>
         </p:txBody>
@@ -11148,7 +11159,7 @@
                 </a:solidFill>
                 <a:latin typeface="Segoe UI"/>
               </a:rPr>
-              <a:t>Illustrative figures for one volume bucket, not real targets. Territory names are generic because the numbers are invented.</a:t>
+              <a:t>Illustrative figures for a single volume bucket. Territory names and values are hypothetical and are not targets.</a:t>
             </a:r>
           </a:p>
         </p:txBody>
@@ -12235,7 +12246,7 @@
                 </a:solidFill>
                 <a:latin typeface="Segoe UI"/>
               </a:rPr>
-              <a:t>You have to finish above your baseline.</a:t>
+              <a:t>A territory must finish above its baseline.</a:t>
             </a:r>
             <a:r>
               <a:rPr sz="1150" b="0" i="0">
@@ -12244,7 +12255,7 @@
                 </a:solidFill>
                 <a:latin typeface="Segoe UI"/>
               </a:rPr>
-              <a:t> At or below the baseline is not a placement, however you rank.</a:t>
+              <a:t> At or below the baseline is not a placement, whatever the rank.</a:t>
             </a:r>
           </a:p>
         </p:txBody>
@@ -12286,7 +12297,7 @@
                 </a:solidFill>
                 <a:latin typeface="Segoe UI"/>
               </a:rPr>
-              <a:t>You are ranked inside your assigned bucket.</a:t>
+              <a:t>Ranking is within the assigned bucket.</a:t>
             </a:r>
             <a:r>
               <a:rPr sz="1150" b="0" i="0">
@@ -12295,7 +12306,7 @@
                 </a:solidFill>
                 <a:latin typeface="Segoe UI"/>
               </a:rPr>
-              <a:t> High, medium and low volume territories are scored separately. RADs are one group, ranked against their combined territory baseline.</a:t>
+              <a:t> High, medium and low volume territories are scored separately. RADs form one group, ranked against their combined territory baseline.</a:t>
             </a:r>
           </a:p>
         </p:txBody>
@@ -12337,7 +12348,7 @@
                 </a:solidFill>
                 <a:latin typeface="Segoe UI"/>
               </a:rPr>
-              <a:t>Ties are resolved by the higher percent growth.</a:t>
+              <a:t>Ties are broken on the higher percent growth.</a:t>
             </a:r>
             <a:r>
               <a:rPr sz="1150" b="0" i="0">
@@ -12517,7 +12528,7 @@
                 </a:solidFill>
                 <a:latin typeface="Segoe UI"/>
               </a:rPr>
-              <a:t>Best enrollment-to-TTP pull-through</a:t>
+              <a:t>Highest enrollment-to-TTP pull-through</a:t>
             </a:r>
             <a:r>
               <a:rPr sz="1150" b="0" i="0">
@@ -12526,7 +12537,7 @@
                 </a:solidFill>
                 <a:latin typeface="Segoe UI"/>
               </a:rPr>
-              <a:t> in your bucket, so this one is about conversion rather than growth.</a:t>
+              <a:t> in the bucket. This award is scored on conversion, not growth.</a:t>
             </a:r>
           </a:p>
         </p:txBody>
@@ -12619,7 +12630,7 @@
                 </a:solidFill>
                 <a:latin typeface="Segoe UI"/>
               </a:rPr>
-              <a:t>The TTP has to occur by November 15, 2026.</a:t>
+              <a:t>TTP must occur by November 15, 2026.</a:t>
             </a:r>
             <a:r>
               <a:rPr sz="1150" b="0" i="0">
@@ -12931,7 +12942,7 @@
                 <a:ea typeface="Segoe UI" pitchFamily="34" charset="-122"/>
                 <a:cs typeface="Segoe UI" pitchFamily="34" charset="-120"/>
               </a:rPr>
-              <a:t>Three winners in every volume bucket,</a:t>
+              <a:t>Three placements in every volume bucket,</a:t>
             </a:r>
           </a:p>
           <a:p>
@@ -12950,7 +12961,7 @@
                 <a:ea typeface="Segoe UI" pitchFamily="34" charset="-122"/>
                 <a:cs typeface="Segoe UI" pitchFamily="34" charset="-120"/>
               </a:rPr>
-              <a:t>separate RAD bucket, and national bonus</a:t>
+              <a:t>a separate RAD bucket, and a national bonus</a:t>
             </a:r>
           </a:p>
         </p:txBody>
@@ -13960,7 +13971,7 @@
                 </a:solidFill>
                 <a:latin typeface="Segoe UI"/>
               </a:rPr>
-              <a:t>per volume bucket, best TTP pull-through</a:t>
+              <a:t>per volume bucket, highest TTP pull-through</a:t>
             </a:r>
           </a:p>
         </p:txBody>
@@ -14791,7 +14802,7 @@
                 </a:solidFill>
                 <a:latin typeface="Segoe UI"/>
               </a:rPr>
-              <a:t>VP option, if enrollments exceed 203</a:t>
+              <a:t>At the VP's option, if enrollments exceed 203</a:t>
             </a:r>
           </a:p>
         </p:txBody>
@@ -14886,7 +14897,7 @@
                 </a:solidFill>
                 <a:latin typeface="Segoe UI"/>
               </a:rPr>
-              <a:t>  $20,000 in each of the three volume buckets, $20,000 in the RAD bucket, and the $10,000 national bonus. You have to finish above your baseline to place.</a:t>
+              <a:t>  $20,000 in each of the three volume buckets, $20,000 in the RAD bucket, and the $10,000 national bonus. A territory must finish above its baseline to place.</a:t>
             </a:r>
           </a:p>
         </p:txBody>
@@ -14928,7 +14939,7 @@
                 </a:solidFill>
                 <a:latin typeface="Segoe UI"/>
               </a:rPr>
-              <a:t>203 is the sum of every territory baseline in the appendix. Figures are proposed for 2H 2026, subject to leadership approval.</a:t>
+              <a:t>The 203 threshold is the sum of every territory baseline in the appendix. Proposed for 2H 2026, subject to leadership approval.</a:t>
             </a:r>
           </a:p>
         </p:txBody>
@@ -15089,7 +15100,7 @@
                 <a:latin typeface="Segoe UI" pitchFamily="34" charset="0"/>
                 <a:cs typeface="Segoe UI" pitchFamily="34" charset="-120"/>
               </a:rPr>
-              <a:t>All 28 territories and the baseline each has to beat,</a:t>
+              <a:t>All 28 territories and their baselines,</a:t>
             </a:r>
           </a:p>
           <a:p>
@@ -15107,7 +15118,7 @@
                 <a:latin typeface="Segoe UI" pitchFamily="34" charset="0"/>
                 <a:cs typeface="Segoe UI" pitchFamily="34" charset="-120"/>
               </a:rPr>
-              <a:t>inside its volume bucket</a:t>
+              <a:t>within each volume bucket</a:t>
             </a:r>
           </a:p>
         </p:txBody>
@@ -18985,7 +18996,7 @@
                 </a:solidFill>
                 <a:latin typeface="Segoe UI"/>
               </a:rPr>
-              <a:t>Baseline is each territory's average enrollments across 4Q 2025, 1Q 2026 and 2Q 2026, scaled to the two month contest window. Desert Plains sits in medium volume at leadership direction. The 28 baselines total 203.</a:t>
+              <a:t>Baseline is each territory's average quarterly enrollments across 4Q 2025, 1Q 2026 and 2Q 2026, scaled to the two-month contest window. Desert Plains is assigned to medium volume at leadership direction. The 28 baselines total 203.</a:t>
             </a:r>
           </a:p>
         </p:txBody>

</xml_diff>